<commit_message>
Staging remaining changes before pull
</commit_message>
<xml_diff>
--- a/AppVerse_AI_Capstone_Presentation.pptx
+++ b/AppVerse_AI_Capstone_Presentation.pptx
@@ -4,6 +4,9 @@
   <p:sldMasterIdLst>
     <p:sldMasterId id="2147483648" r:id="rId1"/>
   </p:sldMasterIdLst>
+  <p:notesMasterIdLst>
+    <p:notesMasterId r:id="rId14"/>
+  </p:notesMasterIdLst>
   <p:sldIdLst>
     <p:sldId id="256" r:id="rId2"/>
     <p:sldId id="257" r:id="rId3"/>
@@ -18,9 +21,6 @@
     <p:sldId id="266" r:id="rId12"/>
     <p:sldId id="267" r:id="rId13"/>
   </p:sldIdLst>
-  <p:notesMasterIdLst>
-    <p:notesMasterId r:id="rId14"/>
-  </p:notesMasterIdLst>
   <p:sldSz cx="12192000" cy="6858000"/>
   <p:notesSz cx="6858000" cy="12192000"/>
   <p:defaultTextStyle>
@@ -115,7 +115,20 @@
       </a:defRPr>
     </a:lvl9pPr>
   </p:defaultTextStyle>
+  <p:extLst>
+    <p:ext uri="{EFAFB233-063F-42B5-8137-9DF3F51BA10A}">
+      <p15:sldGuideLst xmlns:p15="http://schemas.microsoft.com/office/powerpoint/2012/main"/>
+    </p:ext>
+  </p:extLst>
 </p:presentation>
+</file>
+
+<file path=ppt/revisionInfo.xml><?xml version="1.0" encoding="utf-8"?>
+<p1510:revInfo xmlns:a="http://schemas.openxmlformats.org/drawingml/2006/main" xmlns:r="http://schemas.openxmlformats.org/officeDocument/2006/relationships" xmlns:p1510="http://schemas.microsoft.com/office/powerpoint/2015/10/main">
+  <p1510:revLst>
+    <p1510:client id="{B4A3C8B8-A0D7-C54F-6DE5-F81C4749E265}" v="9" dt="2026-06-17T21:57:11.993"/>
+  </p1510:revLst>
+</p1510:revInfo>
 </file>
 
 <file path=ppt/notesMasters/notesMaster1.xml><?xml version="1.0" encoding="utf-8"?>
@@ -153,7 +166,7 @@
         <p:spPr>
           <a:xfrm>
             <a:off x="0" y="0"/>
-            <a:ext cx="2971800" cy="458788"/>
+            <a:ext cx="2971800" cy="611188"/>
           </a:xfrm>
           <a:prstGeom prst="rect">
             <a:avLst/>
@@ -184,7 +197,7 @@
         <p:spPr>
           <a:xfrm>
             <a:off x="3884613" y="0"/>
-            <a:ext cx="2971800" cy="458788"/>
+            <a:ext cx="2971800" cy="611188"/>
           </a:xfrm>
           <a:prstGeom prst="rect">
             <a:avLst/>
@@ -198,9 +211,8 @@
             </a:lvl1pPr>
           </a:lstStyle>
           <a:p>
-            <a:fld id="{5282F153-3F37-0F45-9E97-73ACFA13230C}" type="datetimeFigureOut">
-              <a:rPr lang="en-US"/>
-              <a:t>7/23/19</a:t>
+            <a:fld id="{6CE84533-6DA0-4016-8484-E1EB292A5A78}" type="datetimeFigureOut">
+              <a:t>6/17/2026</a:t>
             </a:fld>
             <a:endParaRPr lang="en-US"/>
           </a:p>
@@ -218,8 +230,8 @@
         </p:nvSpPr>
         <p:spPr>
           <a:xfrm>
-            <a:off x="685800" y="1143000"/>
-            <a:ext cx="5486400" cy="3086100"/>
+            <a:off x="-228600" y="1524000"/>
+            <a:ext cx="7315200" cy="4114800"/>
           </a:xfrm>
           <a:prstGeom prst="rect">
             <a:avLst/>
@@ -251,8 +263,8 @@
         </p:nvSpPr>
         <p:spPr>
           <a:xfrm>
-            <a:off x="685800" y="4400550"/>
-            <a:ext cx="5486400" cy="3600450"/>
+            <a:off x="685800" y="5867400"/>
+            <a:ext cx="5486400" cy="4800600"/>
           </a:xfrm>
           <a:prstGeom prst="rect">
             <a:avLst/>
@@ -310,8 +322,8 @@
         </p:nvSpPr>
         <p:spPr>
           <a:xfrm>
-            <a:off x="0" y="8685213"/>
-            <a:ext cx="2971800" cy="458787"/>
+            <a:off x="0" y="11580813"/>
+            <a:ext cx="2971800" cy="611187"/>
           </a:xfrm>
           <a:prstGeom prst="rect">
             <a:avLst/>
@@ -341,8 +353,8 @@
         </p:nvSpPr>
         <p:spPr>
           <a:xfrm>
-            <a:off x="3884613" y="8685213"/>
-            <a:ext cx="2971800" cy="458787"/>
+            <a:off x="3884613" y="11580813"/>
+            <a:ext cx="2971800" cy="611187"/>
           </a:xfrm>
           <a:prstGeom prst="rect">
             <a:avLst/>
@@ -356,8 +368,7 @@
             </a:lvl1pPr>
           </a:lstStyle>
           <a:p>
-            <a:fld id="{CE5E9CC1-C706-0F49-92D6-E571CC5EEA8F}" type="slidenum">
-              <a:rPr lang="en-US"/>
+            <a:fld id="{0D2838BE-FD00-43A8-91E6-060B85A91ACE}" type="slidenum">
               <a:t>‹#›</a:t>
             </a:fld>
             <a:endParaRPr lang="en-US"/>
@@ -367,7 +378,7 @@
     </p:spTree>
     <p:extLst>
       <p:ext uri="{BB962C8B-B14F-4D97-AF65-F5344CB8AC3E}">
-        <p14:creationId xmlns:p14="http://schemas.microsoft.com/office/powerpoint/2010/main" val="1024086991"/>
+        <p14:creationId xmlns:p14="http://schemas.microsoft.com/office/powerpoint/2010/main" val="1070938998"/>
       </p:ext>
     </p:extLst>
   </p:cSld>
@@ -511,10 +522,6 @@
           <a:bodyPr/>
           <a:lstStyle/>
           <a:p>
-            <a:r>
-              <a:rPr lang="en-US" dirty="0"/>
-              <a:t/>
-            </a:r>
             <a:endParaRPr lang="en-US" dirty="0"/>
           </a:p>
         </p:txBody>
@@ -599,10 +606,6 @@
           <a:bodyPr/>
           <a:lstStyle/>
           <a:p>
-            <a:r>
-              <a:rPr lang="en-US" dirty="0"/>
-              <a:t/>
-            </a:r>
             <a:endParaRPr lang="en-US" dirty="0"/>
           </a:p>
         </p:txBody>
@@ -687,10 +690,6 @@
           <a:bodyPr/>
           <a:lstStyle/>
           <a:p>
-            <a:r>
-              <a:rPr lang="en-US" dirty="0"/>
-              <a:t/>
-            </a:r>
             <a:endParaRPr lang="en-US" dirty="0"/>
           </a:p>
         </p:txBody>
@@ -775,10 +774,6 @@
           <a:bodyPr/>
           <a:lstStyle/>
           <a:p>
-            <a:r>
-              <a:rPr lang="en-US" dirty="0"/>
-              <a:t/>
-            </a:r>
             <a:endParaRPr lang="en-US" dirty="0"/>
           </a:p>
         </p:txBody>
@@ -863,10 +858,6 @@
           <a:bodyPr/>
           <a:lstStyle/>
           <a:p>
-            <a:r>
-              <a:rPr lang="en-US" dirty="0"/>
-              <a:t/>
-            </a:r>
             <a:endParaRPr lang="en-US" dirty="0"/>
           </a:p>
         </p:txBody>
@@ -951,10 +942,6 @@
           <a:bodyPr/>
           <a:lstStyle/>
           <a:p>
-            <a:r>
-              <a:rPr lang="en-US" dirty="0"/>
-              <a:t/>
-            </a:r>
             <a:endParaRPr lang="en-US" dirty="0"/>
           </a:p>
         </p:txBody>
@@ -1039,10 +1026,6 @@
           <a:bodyPr/>
           <a:lstStyle/>
           <a:p>
-            <a:r>
-              <a:rPr lang="en-US" dirty="0"/>
-              <a:t/>
-            </a:r>
             <a:endParaRPr lang="en-US" dirty="0"/>
           </a:p>
         </p:txBody>
@@ -1127,10 +1110,6 @@
           <a:bodyPr/>
           <a:lstStyle/>
           <a:p>
-            <a:r>
-              <a:rPr lang="en-US" dirty="0"/>
-              <a:t/>
-            </a:r>
             <a:endParaRPr lang="en-US" dirty="0"/>
           </a:p>
         </p:txBody>
@@ -1215,10 +1194,6 @@
           <a:bodyPr/>
           <a:lstStyle/>
           <a:p>
-            <a:r>
-              <a:rPr lang="en-US" dirty="0"/>
-              <a:t/>
-            </a:r>
             <a:endParaRPr lang="en-US" dirty="0"/>
           </a:p>
         </p:txBody>
@@ -1303,10 +1278,6 @@
           <a:bodyPr/>
           <a:lstStyle/>
           <a:p>
-            <a:r>
-              <a:rPr lang="en-US" dirty="0"/>
-              <a:t/>
-            </a:r>
             <a:endParaRPr lang="en-US" dirty="0"/>
           </a:p>
         </p:txBody>
@@ -1391,10 +1362,6 @@
           <a:bodyPr/>
           <a:lstStyle/>
           <a:p>
-            <a:r>
-              <a:rPr lang="en-US" dirty="0"/>
-              <a:t/>
-            </a:r>
             <a:endParaRPr lang="en-US" dirty="0"/>
           </a:p>
         </p:txBody>
@@ -1479,10 +1446,6 @@
           <a:bodyPr/>
           <a:lstStyle/>
           <a:p>
-            <a:r>
-              <a:rPr lang="en-US" dirty="0"/>
-              <a:t/>
-            </a:r>
             <a:endParaRPr lang="en-US" dirty="0"/>
           </a:p>
         </p:txBody>
@@ -1556,6 +1519,11 @@
 <file path=ppt/slideMasters/slideMaster1.xml><?xml version="1.0" encoding="utf-8"?>
 <p:sldMaster xmlns:a="http://schemas.openxmlformats.org/drawingml/2006/main" xmlns:r="http://schemas.openxmlformats.org/officeDocument/2006/relationships" xmlns:p="http://schemas.openxmlformats.org/presentationml/2006/main">
   <p:cSld>
+    <p:bg>
+      <p:bgRef idx="1001">
+        <a:schemeClr val="bg1"/>
+      </p:bgRef>
+    </p:bg>
     <p:spTree>
       <p:nvGrpSpPr>
         <p:cNvPr id="1" name=""/>
@@ -1570,6 +1538,54 @@
           <a:chExt cx="0" cy="0"/>
         </a:xfrm>
       </p:grpSpPr>
+      <p:sp>
+        <p:nvSpPr>
+          <p:cNvPr id="3" name="TextBox 2">
+            <a:extLst>
+              <a:ext uri="{FF2B5EF4-FFF2-40B4-BE49-F238E27FC236}">
+                <a16:creationId xmlns:a16="http://schemas.microsoft.com/office/drawing/2014/main" id="{12D87C2D-F5AA-71DE-A5CE-2ED506F4DA70}"/>
+              </a:ext>
+            </a:extLst>
+          </p:cNvPr>
+          <p:cNvSpPr txBox="1"/>
+          <p:nvPr>
+            <p:extLst>
+              <p:ext uri="{1162E1C5-73C7-4A58-AE30-91384D911F3F}">
+                <p184:classification xmlns:p184="http://schemas.microsoft.com/office/powerpoint/2018/4/main" val="ftr"/>
+              </p:ext>
+            </p:extLst>
+          </p:nvPr>
+        </p:nvSpPr>
+        <p:spPr>
+          <a:xfrm>
+            <a:off x="63500" y="6642100"/>
+            <a:ext cx="1222375" cy="152400"/>
+          </a:xfrm>
+          <a:prstGeom prst="rect">
+            <a:avLst/>
+          </a:prstGeom>
+        </p:spPr>
+        <p:txBody>
+          <a:bodyPr horzOverflow="overflow" lIns="0" tIns="0" rIns="0" bIns="0">
+            <a:spAutoFit/>
+          </a:bodyPr>
+          <a:lstStyle/>
+          <a:p>
+            <a:pPr algn="l"/>
+            <a:r>
+              <a:rPr lang="en-US" sz="1000">
+                <a:solidFill>
+                  <a:srgbClr val="000000">
+                    <a:alpha val="50000"/>
+                  </a:srgbClr>
+                </a:solidFill>
+                <a:latin typeface="Aptos" panose="020B0004020202020204" pitchFamily="34" charset="0"/>
+              </a:rPr>
+              <a:t>Internal - General Use</a:t>
+            </a:r>
+          </a:p>
+        </p:txBody>
+      </p:sp>
     </p:spTree>
   </p:cSld>
   <p:clrMap bg1="lt1" tx1="dk1" bg2="lt2" tx2="dk2" accent1="accent1" accent2="accent2" accent3="accent3" accent4="accent4" accent5="accent5" accent6="accent6" hlink="hlink" folHlink="folHlink"/>
@@ -1838,6 +1854,7 @@
         <a:solidFill>
           <a:srgbClr val="0A0E1A"/>
         </a:solidFill>
+        <a:effectLst/>
       </p:bgPr>
     </p:bg>
     <p:spTree>
@@ -1919,11 +1936,11 @@
           <a:bodyPr wrap="square" rtlCol="0" anchor="ctr"/>
           <a:lstStyle/>
           <a:p>
-            <a:pPr indent="0" marL="0">
-              <a:buNone/>
-            </a:pPr>
-            <a:r>
-              <a:rPr lang="en-US" sz="1400" b="1" spc="300" kern="0" dirty="0">
+            <a:pPr marL="0" indent="0">
+              <a:buNone/>
+            </a:pPr>
+            <a:r>
+              <a:rPr lang="en-US" sz="1400" b="1" kern="0" spc="300" dirty="0">
                 <a:solidFill>
                   <a:srgbClr val="22D3B6"/>
                 </a:solidFill>
@@ -1958,7 +1975,7 @@
           <a:bodyPr wrap="square" rtlCol="0" anchor="ctr"/>
           <a:lstStyle/>
           <a:p>
-            <a:pPr indent="0" marL="0">
+            <a:pPr marL="0" indent="0">
               <a:buNone/>
             </a:pPr>
             <a:r>
@@ -1997,7 +2014,7 @@
           <a:bodyPr wrap="square" rtlCol="0" anchor="ctr"/>
           <a:lstStyle/>
           <a:p>
-            <a:pPr indent="0" marL="0">
+            <a:pPr marL="0" indent="0">
               <a:buNone/>
             </a:pPr>
             <a:r>
@@ -2036,7 +2053,7 @@
           <a:bodyPr wrap="square" rtlCol="0" anchor="ctr"/>
           <a:lstStyle/>
           <a:p>
-            <a:pPr indent="0" marL="0">
+            <a:pPr marL="0" indent="0">
               <a:lnSpc>
                 <a:spcPts val="2000"/>
               </a:lnSpc>
@@ -2056,7 +2073,7 @@
             <a:endParaRPr lang="en-US" sz="1300" dirty="0"/>
           </a:p>
           <a:p>
-            <a:pPr indent="0" marL="0">
+            <a:pPr marL="0" indent="0">
               <a:lnSpc>
                 <a:spcPts val="2000"/>
               </a:lnSpc>
@@ -2089,9 +2106,7 @@
             <a:ext cx="2377440" cy="502920"/>
           </a:xfrm>
           <a:prstGeom prst="rect">
-            <a:avLst>
-              <a:gd name="adj" fmla="val 14545"/>
-            </a:avLst>
+            <a:avLst/>
           </a:prstGeom>
           <a:solidFill>
             <a:srgbClr val="11162B"/>
@@ -2125,7 +2140,7 @@
           <a:bodyPr wrap="square" rtlCol="0" anchor="ctr"/>
           <a:lstStyle/>
           <a:p>
-            <a:pPr algn="ctr" indent="0" marL="0">
+            <a:pPr marL="0" indent="0" algn="ctr">
               <a:buNone/>
             </a:pPr>
             <a:r>
@@ -2191,7 +2206,7 @@
           <a:bodyPr wrap="square" rtlCol="0" anchor="ctr"/>
           <a:lstStyle/>
           <a:p>
-            <a:pPr algn="ctr" indent="0" marL="0">
+            <a:pPr marL="0" indent="0" algn="ctr">
               <a:buNone/>
             </a:pPr>
             <a:r>
@@ -2257,7 +2272,7 @@
           <a:bodyPr wrap="square" rtlCol="0" anchor="ctr"/>
           <a:lstStyle/>
           <a:p>
-            <a:pPr algn="ctr" indent="0" marL="0">
+            <a:pPr marL="0" indent="0" algn="ctr">
               <a:buNone/>
             </a:pPr>
             <a:r>
@@ -2323,7 +2338,7 @@
           <a:bodyPr wrap="square" rtlCol="0" anchor="ctr"/>
           <a:lstStyle/>
           <a:p>
-            <a:pPr algn="ctr" indent="0" marL="0">
+            <a:pPr marL="0" indent="0" algn="ctr">
               <a:buNone/>
             </a:pPr>
             <a:r>
@@ -2359,24 +2374,36 @@
           <a:ln/>
         </p:spPr>
         <p:txBody>
-          <a:bodyPr wrap="square" rtlCol="0" anchor="ctr"/>
-          <a:lstStyle/>
-          <a:p>
-            <a:pPr indent="0" marL="0">
-              <a:buNone/>
-            </a:pPr>
+          <a:bodyPr wrap="square" lIns="91440" tIns="45720" rIns="91440" bIns="45720" rtlCol="0" anchor="ctr"/>
+          <a:lstStyle/>
+          <a:p>
+            <a:r>
+              <a:rPr lang="en-US" sz="1200">
+                <a:solidFill>
+                  <a:srgbClr val="8A90B5"/>
+                </a:solidFill>
+                <a:latin typeface="Calibri"/>
+                <a:ea typeface="Calibri"/>
+                <a:cs typeface="Calibri"/>
+              </a:rPr>
+              <a:t>Gopidi Anugna</a:t>
+            </a:r>
             <a:r>
               <a:rPr lang="en-US" sz="1200" dirty="0">
                 <a:solidFill>
                   <a:srgbClr val="8A90B5"/>
                 </a:solidFill>
-                <a:latin typeface="Calibri" pitchFamily="34" charset="0"/>
-                <a:ea typeface="Calibri" pitchFamily="34" charset="-122"/>
-                <a:cs typeface="Calibri" pitchFamily="34" charset="-120"/>
-              </a:rPr>
-              <a:t>Lil Anugna Reddy   |   Java Full Stack Development</a:t>
-            </a:r>
-            <a:endParaRPr lang="en-US" sz="1200" dirty="0"/>
+                <a:latin typeface="Calibri"/>
+                <a:ea typeface="Calibri"/>
+                <a:cs typeface="Calibri"/>
+              </a:rPr>
+              <a:t> Reddy   |   Java Full Stack Development</a:t>
+            </a:r>
+            <a:endParaRPr lang="en-US" sz="1200">
+              <a:latin typeface="Calibri"/>
+              <a:ea typeface="Calibri"/>
+              <a:cs typeface="Calibri"/>
+            </a:endParaRPr>
           </a:p>
         </p:txBody>
       </p:sp>
@@ -2396,6 +2423,7 @@
         <a:solidFill>
           <a:srgbClr val="F7F8FC"/>
         </a:solidFill>
+        <a:effectLst/>
       </p:bgPr>
     </p:bg>
     <p:spTree>
@@ -2433,11 +2461,11 @@
           <a:bodyPr wrap="square" rtlCol="0" anchor="ctr"/>
           <a:lstStyle/>
           <a:p>
-            <a:pPr indent="0" marL="0">
-              <a:buNone/>
-            </a:pPr>
-            <a:r>
-              <a:rPr lang="en-US" sz="1300" b="1" spc="200" kern="0" dirty="0">
+            <a:pPr marL="0" indent="0">
+              <a:buNone/>
+            </a:pPr>
+            <a:r>
+              <a:rPr lang="en-US" sz="1300" b="1" kern="0" spc="200" dirty="0">
                 <a:solidFill>
                   <a:srgbClr val="6366F1"/>
                 </a:solidFill>
@@ -2472,7 +2500,7 @@
           <a:bodyPr wrap="square" rtlCol="0" anchor="ctr"/>
           <a:lstStyle/>
           <a:p>
-            <a:pPr indent="0" marL="0">
+            <a:pPr marL="0" indent="0">
               <a:buNone/>
             </a:pPr>
             <a:r>
@@ -2516,7 +2544,7 @@
             <a:prstDash val="solid"/>
           </a:ln>
           <a:effectLst>
-            <a:outerShdw sx="100000" sy="100000" kx="0" ky="0" algn="bl" rotWithShape="0" blurRad="101600" dist="25400" dir="5400000">
+            <a:outerShdw blurRad="101600" dist="25400" dir="5400000" algn="bl" rotWithShape="0">
               <a:srgbClr val="1A1D2E">
                 <a:alpha val="8000"/>
               </a:srgbClr>
@@ -2565,7 +2593,7 @@
           <a:bodyPr wrap="square" rtlCol="0" anchor="ctr"/>
           <a:lstStyle/>
           <a:p>
-            <a:pPr indent="0" marL="0">
+            <a:pPr marL="0" indent="0">
               <a:buNone/>
             </a:pPr>
             <a:r>
@@ -2604,7 +2632,7 @@
           <a:bodyPr wrap="square" rtlCol="0" anchor="ctr"/>
           <a:lstStyle/>
           <a:p>
-            <a:pPr indent="0" marL="0">
+            <a:pPr marL="0" indent="0">
               <a:lnSpc>
                 <a:spcPts val="1400"/>
               </a:lnSpc>
@@ -2651,7 +2679,7 @@
             <a:prstDash val="solid"/>
           </a:ln>
           <a:effectLst>
-            <a:outerShdw sx="100000" sy="100000" kx="0" ky="0" algn="bl" rotWithShape="0" blurRad="101600" dist="25400" dir="5400000">
+            <a:outerShdw blurRad="101600" dist="25400" dir="5400000" algn="bl" rotWithShape="0">
               <a:srgbClr val="1A1D2E">
                 <a:alpha val="8000"/>
               </a:srgbClr>
@@ -2700,7 +2728,7 @@
           <a:bodyPr wrap="square" rtlCol="0" anchor="ctr"/>
           <a:lstStyle/>
           <a:p>
-            <a:pPr indent="0" marL="0">
+            <a:pPr marL="0" indent="0">
               <a:buNone/>
             </a:pPr>
             <a:r>
@@ -2739,7 +2767,7 @@
           <a:bodyPr wrap="square" rtlCol="0" anchor="ctr"/>
           <a:lstStyle/>
           <a:p>
-            <a:pPr indent="0" marL="0">
+            <a:pPr marL="0" indent="0">
               <a:lnSpc>
                 <a:spcPts val="1400"/>
               </a:lnSpc>
@@ -2786,7 +2814,7 @@
             <a:prstDash val="solid"/>
           </a:ln>
           <a:effectLst>
-            <a:outerShdw sx="100000" sy="100000" kx="0" ky="0" algn="bl" rotWithShape="0" blurRad="101600" dist="25400" dir="5400000">
+            <a:outerShdw blurRad="101600" dist="25400" dir="5400000" algn="bl" rotWithShape="0">
               <a:srgbClr val="1A1D2E">
                 <a:alpha val="8000"/>
               </a:srgbClr>
@@ -2835,7 +2863,7 @@
           <a:bodyPr wrap="square" rtlCol="0" anchor="ctr"/>
           <a:lstStyle/>
           <a:p>
-            <a:pPr indent="0" marL="0">
+            <a:pPr marL="0" indent="0">
               <a:buNone/>
             </a:pPr>
             <a:r>
@@ -2874,7 +2902,7 @@
           <a:bodyPr wrap="square" rtlCol="0" anchor="ctr"/>
           <a:lstStyle/>
           <a:p>
-            <a:pPr indent="0" marL="0">
+            <a:pPr marL="0" indent="0">
               <a:lnSpc>
                 <a:spcPts val="1400"/>
               </a:lnSpc>
@@ -2921,7 +2949,7 @@
             <a:prstDash val="solid"/>
           </a:ln>
           <a:effectLst>
-            <a:outerShdw sx="100000" sy="100000" kx="0" ky="0" algn="bl" rotWithShape="0" blurRad="101600" dist="25400" dir="5400000">
+            <a:outerShdw blurRad="101600" dist="25400" dir="5400000" algn="bl" rotWithShape="0">
               <a:srgbClr val="1A1D2E">
                 <a:alpha val="8000"/>
               </a:srgbClr>
@@ -2970,7 +2998,7 @@
           <a:bodyPr wrap="square" rtlCol="0" anchor="ctr"/>
           <a:lstStyle/>
           <a:p>
-            <a:pPr indent="0" marL="0">
+            <a:pPr marL="0" indent="0">
               <a:buNone/>
             </a:pPr>
             <a:r>
@@ -3009,7 +3037,7 @@
           <a:bodyPr wrap="square" rtlCol="0" anchor="ctr"/>
           <a:lstStyle/>
           <a:p>
-            <a:pPr indent="0" marL="0">
+            <a:pPr marL="0" indent="0">
               <a:lnSpc>
                 <a:spcPts val="1400"/>
               </a:lnSpc>
@@ -3056,7 +3084,7 @@
             <a:prstDash val="solid"/>
           </a:ln>
           <a:effectLst>
-            <a:outerShdw sx="100000" sy="100000" kx="0" ky="0" algn="bl" rotWithShape="0" blurRad="101600" dist="25400" dir="5400000">
+            <a:outerShdw blurRad="101600" dist="25400" dir="5400000" algn="bl" rotWithShape="0">
               <a:srgbClr val="1A1D2E">
                 <a:alpha val="8000"/>
               </a:srgbClr>
@@ -3105,7 +3133,7 @@
           <a:bodyPr wrap="square" rtlCol="0" anchor="ctr"/>
           <a:lstStyle/>
           <a:p>
-            <a:pPr indent="0" marL="0">
+            <a:pPr marL="0" indent="0">
               <a:buNone/>
             </a:pPr>
             <a:r>
@@ -3144,7 +3172,7 @@
           <a:bodyPr wrap="square" rtlCol="0" anchor="ctr"/>
           <a:lstStyle/>
           <a:p>
-            <a:pPr indent="0" marL="0">
+            <a:pPr marL="0" indent="0">
               <a:lnSpc>
                 <a:spcPts val="1400"/>
               </a:lnSpc>
@@ -3191,7 +3219,7 @@
             <a:prstDash val="solid"/>
           </a:ln>
           <a:effectLst>
-            <a:outerShdw sx="100000" sy="100000" kx="0" ky="0" algn="bl" rotWithShape="0" blurRad="101600" dist="25400" dir="5400000">
+            <a:outerShdw blurRad="101600" dist="25400" dir="5400000" algn="bl" rotWithShape="0">
               <a:srgbClr val="1A1D2E">
                 <a:alpha val="8000"/>
               </a:srgbClr>
@@ -3240,7 +3268,7 @@
           <a:bodyPr wrap="square" rtlCol="0" anchor="ctr"/>
           <a:lstStyle/>
           <a:p>
-            <a:pPr indent="0" marL="0">
+            <a:pPr marL="0" indent="0">
               <a:buNone/>
             </a:pPr>
             <a:r>
@@ -3279,7 +3307,7 @@
           <a:bodyPr wrap="square" rtlCol="0" anchor="ctr"/>
           <a:lstStyle/>
           <a:p>
-            <a:pPr indent="0" marL="0">
+            <a:pPr marL="0" indent="0">
               <a:lnSpc>
                 <a:spcPts val="1400"/>
               </a:lnSpc>
@@ -3321,7 +3349,7 @@
           <a:bodyPr wrap="square" rtlCol="0" anchor="ctr"/>
           <a:lstStyle/>
           <a:p>
-            <a:pPr algn="l" indent="0" marL="0">
+            <a:pPr marL="0" indent="0" algn="l">
               <a:buNone/>
             </a:pPr>
             <a:r>
@@ -3360,7 +3388,7 @@
           <a:bodyPr wrap="square" rtlCol="0" anchor="ctr"/>
           <a:lstStyle/>
           <a:p>
-            <a:pPr algn="r" indent="0" marL="0">
+            <a:pPr marL="0" indent="0" algn="r">
               <a:buNone/>
             </a:pPr>
             <a:r>
@@ -3394,6 +3422,7 @@
         <a:solidFill>
           <a:srgbClr val="0A0E1A"/>
         </a:solidFill>
+        <a:effectLst/>
       </p:bgPr>
     </p:bg>
     <p:spTree>
@@ -3431,11 +3460,11 @@
           <a:bodyPr wrap="square" rtlCol="0" anchor="ctr"/>
           <a:lstStyle/>
           <a:p>
-            <a:pPr indent="0" marL="0">
-              <a:buNone/>
-            </a:pPr>
-            <a:r>
-              <a:rPr lang="en-US" sz="1300" b="1" spc="200" kern="0" dirty="0">
+            <a:pPr marL="0" indent="0">
+              <a:buNone/>
+            </a:pPr>
+            <a:r>
+              <a:rPr lang="en-US" sz="1300" b="1" kern="0" spc="200" dirty="0">
                 <a:solidFill>
                   <a:srgbClr val="22D3B6"/>
                 </a:solidFill>
@@ -3470,7 +3499,7 @@
           <a:bodyPr wrap="square" rtlCol="0" anchor="ctr"/>
           <a:lstStyle/>
           <a:p>
-            <a:pPr indent="0" marL="0">
+            <a:pPr marL="0" indent="0">
               <a:buNone/>
             </a:pPr>
             <a:r>
@@ -3509,7 +3538,7 @@
           <a:bodyPr wrap="square" rtlCol="0" anchor="ctr"/>
           <a:lstStyle/>
           <a:p>
-            <a:pPr indent="0" marL="0">
+            <a:pPr marL="0" indent="0">
               <a:buNone/>
             </a:pPr>
             <a:r>
@@ -3748,7 +3777,7 @@
           <a:bodyPr wrap="square" rtlCol="0" anchor="ctr"/>
           <a:lstStyle/>
           <a:p>
-            <a:pPr indent="0" marL="0">
+            <a:pPr marL="0" indent="0">
               <a:buNone/>
             </a:pPr>
             <a:r>
@@ -3987,7 +4016,7 @@
           <a:bodyPr wrap="square" rtlCol="0" anchor="ctr"/>
           <a:lstStyle/>
           <a:p>
-            <a:pPr algn="l" indent="0" marL="0">
+            <a:pPr marL="0" indent="0" algn="l">
               <a:buNone/>
             </a:pPr>
             <a:r>
@@ -4026,7 +4055,7 @@
           <a:bodyPr wrap="square" rtlCol="0" anchor="ctr"/>
           <a:lstStyle/>
           <a:p>
-            <a:pPr algn="r" indent="0" marL="0">
+            <a:pPr marL="0" indent="0" algn="r">
               <a:buNone/>
             </a:pPr>
             <a:r>
@@ -4060,6 +4089,7 @@
         <a:solidFill>
           <a:srgbClr val="0A0E1A"/>
         </a:solidFill>
+        <a:effectLst/>
       </p:bgPr>
     </p:bg>
     <p:spTree>
@@ -4119,11 +4149,11 @@
           <a:bodyPr wrap="square" rtlCol="0" anchor="ctr"/>
           <a:lstStyle/>
           <a:p>
-            <a:pPr indent="0" marL="0">
-              <a:buNone/>
-            </a:pPr>
-            <a:r>
-              <a:rPr lang="en-US" sz="1300" b="1" spc="300" kern="0" dirty="0">
+            <a:pPr marL="0" indent="0">
+              <a:buNone/>
+            </a:pPr>
+            <a:r>
+              <a:rPr lang="en-US" sz="1300" b="1" kern="0" spc="300" dirty="0">
                 <a:solidFill>
                   <a:srgbClr val="22D3B6"/>
                 </a:solidFill>
@@ -4158,7 +4188,7 @@
           <a:bodyPr wrap="square" rtlCol="0" anchor="ctr"/>
           <a:lstStyle/>
           <a:p>
-            <a:pPr indent="0" marL="0">
+            <a:pPr marL="0" indent="0">
               <a:lnSpc>
                 <a:spcPts val="4000"/>
               </a:lnSpc>
@@ -4178,7 +4208,7 @@
             <a:endParaRPr lang="en-US" sz="3400" dirty="0"/>
           </a:p>
           <a:p>
-            <a:pPr indent="0" marL="0">
+            <a:pPr marL="0" indent="0">
               <a:lnSpc>
                 <a:spcPts val="4000"/>
               </a:lnSpc>
@@ -4220,7 +4250,7 @@
           <a:bodyPr wrap="square" rtlCol="0" anchor="ctr"/>
           <a:lstStyle/>
           <a:p>
-            <a:pPr indent="0" marL="0">
+            <a:pPr marL="0" indent="0">
               <a:lnSpc>
                 <a:spcPts val="2200"/>
               </a:lnSpc>
@@ -4289,7 +4319,7 @@
           <a:bodyPr wrap="square" rtlCol="0" anchor="ctr"/>
           <a:lstStyle/>
           <a:p>
-            <a:pPr algn="ctr" indent="0" marL="0">
+            <a:pPr marL="0" indent="0" algn="ctr">
               <a:buNone/>
             </a:pPr>
             <a:r>
@@ -4355,7 +4385,7 @@
           <a:bodyPr wrap="square" rtlCol="0" anchor="ctr"/>
           <a:lstStyle/>
           <a:p>
-            <a:pPr algn="ctr" indent="0" marL="0">
+            <a:pPr marL="0" indent="0" algn="ctr">
               <a:buNone/>
             </a:pPr>
             <a:r>
@@ -4421,7 +4451,7 @@
           <a:bodyPr wrap="square" rtlCol="0" anchor="ctr"/>
           <a:lstStyle/>
           <a:p>
-            <a:pPr algn="ctr" indent="0" marL="0">
+            <a:pPr marL="0" indent="0" algn="ctr">
               <a:buNone/>
             </a:pPr>
             <a:r>
@@ -4487,7 +4517,7 @@
           <a:bodyPr wrap="square" rtlCol="0" anchor="ctr"/>
           <a:lstStyle/>
           <a:p>
-            <a:pPr algn="ctr" indent="0" marL="0">
+            <a:pPr marL="0" indent="0" algn="ctr">
               <a:buNone/>
             </a:pPr>
             <a:r>
@@ -4526,7 +4556,7 @@
           <a:bodyPr wrap="square" rtlCol="0" anchor="ctr"/>
           <a:lstStyle/>
           <a:p>
-            <a:pPr indent="0" marL="0">
+            <a:pPr marL="0" indent="0">
               <a:buNone/>
             </a:pPr>
             <a:r>
@@ -4560,6 +4590,7 @@
         <a:solidFill>
           <a:srgbClr val="F7F8FC"/>
         </a:solidFill>
+        <a:effectLst/>
       </p:bgPr>
     </p:bg>
     <p:spTree>
@@ -4597,11 +4628,11 @@
           <a:bodyPr wrap="square" rtlCol="0" anchor="ctr"/>
           <a:lstStyle/>
           <a:p>
-            <a:pPr indent="0" marL="0">
-              <a:buNone/>
-            </a:pPr>
-            <a:r>
-              <a:rPr lang="en-US" sz="1300" b="1" spc="200" kern="0" dirty="0">
+            <a:pPr marL="0" indent="0">
+              <a:buNone/>
+            </a:pPr>
+            <a:r>
+              <a:rPr lang="en-US" sz="1300" b="1" kern="0" spc="200" dirty="0">
                 <a:solidFill>
                   <a:srgbClr val="6366F1"/>
                 </a:solidFill>
@@ -4636,7 +4667,7 @@
           <a:bodyPr wrap="square" rtlCol="0" anchor="ctr"/>
           <a:lstStyle/>
           <a:p>
-            <a:pPr indent="0" marL="0">
+            <a:pPr marL="0" indent="0">
               <a:buNone/>
             </a:pPr>
             <a:r>
@@ -4675,7 +4706,7 @@
           <a:bodyPr wrap="square" rtlCol="0" anchor="ctr"/>
           <a:lstStyle/>
           <a:p>
-            <a:pPr indent="0" marL="0">
+            <a:pPr marL="0" indent="0">
               <a:lnSpc>
                 <a:spcPts val="2200"/>
               </a:lnSpc>
@@ -4722,7 +4753,7 @@
             <a:prstDash val="solid"/>
           </a:ln>
           <a:effectLst>
-            <a:outerShdw sx="100000" sy="100000" kx="0" ky="0" algn="bl" rotWithShape="0" blurRad="101600" dist="25400" dir="5400000">
+            <a:outerShdw blurRad="101600" dist="25400" dir="5400000" algn="bl" rotWithShape="0">
               <a:srgbClr val="1A1D2E">
                 <a:alpha val="8000"/>
               </a:srgbClr>
@@ -4771,7 +4802,7 @@
           <a:bodyPr wrap="square" rtlCol="0" anchor="ctr"/>
           <a:lstStyle/>
           <a:p>
-            <a:pPr algn="ctr" indent="0" marL="0">
+            <a:pPr marL="0" indent="0" algn="ctr">
               <a:buNone/>
             </a:pPr>
             <a:r>
@@ -4810,7 +4841,7 @@
           <a:bodyPr wrap="square" rtlCol="0" anchor="ctr"/>
           <a:lstStyle/>
           <a:p>
-            <a:pPr indent="0" marL="0">
+            <a:pPr marL="0" indent="0">
               <a:buNone/>
             </a:pPr>
             <a:r>
@@ -4849,7 +4880,7 @@
           <a:bodyPr wrap="square" rtlCol="0" anchor="ctr"/>
           <a:lstStyle/>
           <a:p>
-            <a:pPr indent="0" marL="0">
+            <a:pPr marL="0" indent="0">
               <a:lnSpc>
                 <a:spcPts val="1600"/>
               </a:lnSpc>
@@ -4896,7 +4927,7 @@
             <a:prstDash val="solid"/>
           </a:ln>
           <a:effectLst>
-            <a:outerShdw sx="100000" sy="100000" kx="0" ky="0" algn="bl" rotWithShape="0" blurRad="101600" dist="25400" dir="5400000">
+            <a:outerShdw blurRad="101600" dist="25400" dir="5400000" algn="bl" rotWithShape="0">
               <a:srgbClr val="1A1D2E">
                 <a:alpha val="8000"/>
               </a:srgbClr>
@@ -4945,7 +4976,7 @@
           <a:bodyPr wrap="square" rtlCol="0" anchor="ctr"/>
           <a:lstStyle/>
           <a:p>
-            <a:pPr algn="ctr" indent="0" marL="0">
+            <a:pPr marL="0" indent="0" algn="ctr">
               <a:buNone/>
             </a:pPr>
             <a:r>
@@ -4984,7 +5015,7 @@
           <a:bodyPr wrap="square" rtlCol="0" anchor="ctr"/>
           <a:lstStyle/>
           <a:p>
-            <a:pPr indent="0" marL="0">
+            <a:pPr marL="0" indent="0">
               <a:buNone/>
             </a:pPr>
             <a:r>
@@ -5023,7 +5054,7 @@
           <a:bodyPr wrap="square" rtlCol="0" anchor="ctr"/>
           <a:lstStyle/>
           <a:p>
-            <a:pPr indent="0" marL="0">
+            <a:pPr marL="0" indent="0">
               <a:lnSpc>
                 <a:spcPts val="1600"/>
               </a:lnSpc>
@@ -5070,7 +5101,7 @@
             <a:prstDash val="solid"/>
           </a:ln>
           <a:effectLst>
-            <a:outerShdw sx="100000" sy="100000" kx="0" ky="0" algn="bl" rotWithShape="0" blurRad="101600" dist="25400" dir="5400000">
+            <a:outerShdw blurRad="101600" dist="25400" dir="5400000" algn="bl" rotWithShape="0">
               <a:srgbClr val="1A1D2E">
                 <a:alpha val="8000"/>
               </a:srgbClr>
@@ -5119,7 +5150,7 @@
           <a:bodyPr wrap="square" rtlCol="0" anchor="ctr"/>
           <a:lstStyle/>
           <a:p>
-            <a:pPr algn="ctr" indent="0" marL="0">
+            <a:pPr marL="0" indent="0" algn="ctr">
               <a:buNone/>
             </a:pPr>
             <a:r>
@@ -5158,7 +5189,7 @@
           <a:bodyPr wrap="square" rtlCol="0" anchor="ctr"/>
           <a:lstStyle/>
           <a:p>
-            <a:pPr indent="0" marL="0">
+            <a:pPr marL="0" indent="0">
               <a:buNone/>
             </a:pPr>
             <a:r>
@@ -5197,7 +5228,7 @@
           <a:bodyPr wrap="square" rtlCol="0" anchor="ctr"/>
           <a:lstStyle/>
           <a:p>
-            <a:pPr indent="0" marL="0">
+            <a:pPr marL="0" indent="0">
               <a:lnSpc>
                 <a:spcPts val="1600"/>
               </a:lnSpc>
@@ -5244,7 +5275,7 @@
             <a:prstDash val="solid"/>
           </a:ln>
           <a:effectLst>
-            <a:outerShdw sx="100000" sy="100000" kx="0" ky="0" algn="bl" rotWithShape="0" blurRad="101600" dist="25400" dir="5400000">
+            <a:outerShdw blurRad="101600" dist="25400" dir="5400000" algn="bl" rotWithShape="0">
               <a:srgbClr val="1A1D2E">
                 <a:alpha val="8000"/>
               </a:srgbClr>
@@ -5293,7 +5324,7 @@
           <a:bodyPr wrap="square" rtlCol="0" anchor="ctr"/>
           <a:lstStyle/>
           <a:p>
-            <a:pPr algn="ctr" indent="0" marL="0">
+            <a:pPr marL="0" indent="0" algn="ctr">
               <a:buNone/>
             </a:pPr>
             <a:r>
@@ -5332,7 +5363,7 @@
           <a:bodyPr wrap="square" rtlCol="0" anchor="ctr"/>
           <a:lstStyle/>
           <a:p>
-            <a:pPr indent="0" marL="0">
+            <a:pPr marL="0" indent="0">
               <a:buNone/>
             </a:pPr>
             <a:r>
@@ -5371,7 +5402,7 @@
           <a:bodyPr wrap="square" rtlCol="0" anchor="ctr"/>
           <a:lstStyle/>
           <a:p>
-            <a:pPr indent="0" marL="0">
+            <a:pPr marL="0" indent="0">
               <a:lnSpc>
                 <a:spcPts val="1600"/>
               </a:lnSpc>
@@ -5413,7 +5444,7 @@
           <a:bodyPr wrap="square" rtlCol="0" anchor="ctr"/>
           <a:lstStyle/>
           <a:p>
-            <a:pPr algn="l" indent="0" marL="0">
+            <a:pPr marL="0" indent="0" algn="l">
               <a:buNone/>
             </a:pPr>
             <a:r>
@@ -5452,7 +5483,7 @@
           <a:bodyPr wrap="square" rtlCol="0" anchor="ctr"/>
           <a:lstStyle/>
           <a:p>
-            <a:pPr algn="r" indent="0" marL="0">
+            <a:pPr marL="0" indent="0" algn="r">
               <a:buNone/>
             </a:pPr>
             <a:r>
@@ -5486,6 +5517,7 @@
         <a:solidFill>
           <a:srgbClr val="0A0E1A"/>
         </a:solidFill>
+        <a:effectLst/>
       </p:bgPr>
     </p:bg>
     <p:spTree>
@@ -5523,11 +5555,11 @@
           <a:bodyPr wrap="square" rtlCol="0" anchor="ctr"/>
           <a:lstStyle/>
           <a:p>
-            <a:pPr indent="0" marL="0">
-              <a:buNone/>
-            </a:pPr>
-            <a:r>
-              <a:rPr lang="en-US" sz="1300" b="1" spc="200" kern="0" dirty="0">
+            <a:pPr marL="0" indent="0">
+              <a:buNone/>
+            </a:pPr>
+            <a:r>
+              <a:rPr lang="en-US" sz="1300" b="1" kern="0" spc="200" dirty="0">
                 <a:solidFill>
                   <a:srgbClr val="22D3B6"/>
                 </a:solidFill>
@@ -5562,7 +5594,7 @@
           <a:bodyPr wrap="square" rtlCol="0" anchor="ctr"/>
           <a:lstStyle/>
           <a:p>
-            <a:pPr indent="0" marL="0">
+            <a:pPr marL="0" indent="0">
               <a:buNone/>
             </a:pPr>
             <a:r>
@@ -5628,7 +5660,7 @@
           <a:bodyPr wrap="square" rtlCol="0" anchor="ctr"/>
           <a:lstStyle/>
           <a:p>
-            <a:pPr indent="0" marL="0">
+            <a:pPr marL="0" indent="0">
               <a:buNone/>
             </a:pPr>
             <a:r>
@@ -5667,7 +5699,7 @@
           <a:bodyPr wrap="square" rtlCol="0" anchor="ctr"/>
           <a:lstStyle/>
           <a:p>
-            <a:pPr indent="0" marL="0">
+            <a:pPr marL="0" indent="0">
               <a:lnSpc>
                 <a:spcPts val="1600"/>
               </a:lnSpc>
@@ -5709,7 +5741,7 @@
           <a:bodyPr wrap="square" rtlCol="0" anchor="ctr"/>
           <a:lstStyle/>
           <a:p>
-            <a:pPr indent="0" marL="0">
+            <a:pPr marL="0" indent="0">
               <a:lnSpc>
                 <a:spcPts val="1300"/>
               </a:lnSpc>
@@ -5778,7 +5810,7 @@
           <a:bodyPr wrap="square" rtlCol="0" anchor="ctr"/>
           <a:lstStyle/>
           <a:p>
-            <a:pPr indent="0" marL="0">
+            <a:pPr marL="0" indent="0">
               <a:buNone/>
             </a:pPr>
             <a:r>
@@ -5817,7 +5849,7 @@
           <a:bodyPr wrap="square" rtlCol="0" anchor="ctr"/>
           <a:lstStyle/>
           <a:p>
-            <a:pPr indent="0" marL="0">
+            <a:pPr marL="0" indent="0">
               <a:lnSpc>
                 <a:spcPts val="1600"/>
               </a:lnSpc>
@@ -5859,7 +5891,7 @@
           <a:bodyPr wrap="square" rtlCol="0" anchor="ctr"/>
           <a:lstStyle/>
           <a:p>
-            <a:pPr indent="0" marL="0">
+            <a:pPr marL="0" indent="0">
               <a:lnSpc>
                 <a:spcPts val="1300"/>
               </a:lnSpc>
@@ -5928,7 +5960,7 @@
           <a:bodyPr wrap="square" rtlCol="0" anchor="ctr"/>
           <a:lstStyle/>
           <a:p>
-            <a:pPr indent="0" marL="0">
+            <a:pPr marL="0" indent="0">
               <a:buNone/>
             </a:pPr>
             <a:r>
@@ -5967,7 +5999,7 @@
           <a:bodyPr wrap="square" rtlCol="0" anchor="ctr"/>
           <a:lstStyle/>
           <a:p>
-            <a:pPr indent="0" marL="0">
+            <a:pPr marL="0" indent="0">
               <a:lnSpc>
                 <a:spcPts val="1600"/>
               </a:lnSpc>
@@ -6009,7 +6041,7 @@
           <a:bodyPr wrap="square" rtlCol="0" anchor="ctr"/>
           <a:lstStyle/>
           <a:p>
-            <a:pPr indent="0" marL="0">
+            <a:pPr marL="0" indent="0">
               <a:lnSpc>
                 <a:spcPts val="1300"/>
               </a:lnSpc>
@@ -6078,7 +6110,7 @@
           <a:bodyPr wrap="square" rtlCol="0" anchor="ctr"/>
           <a:lstStyle/>
           <a:p>
-            <a:pPr indent="0" marL="0">
+            <a:pPr marL="0" indent="0">
               <a:buNone/>
             </a:pPr>
             <a:r>
@@ -6117,7 +6149,7 @@
           <a:bodyPr wrap="square" rtlCol="0" anchor="ctr"/>
           <a:lstStyle/>
           <a:p>
-            <a:pPr indent="0" marL="0">
+            <a:pPr marL="0" indent="0">
               <a:lnSpc>
                 <a:spcPts val="1600"/>
               </a:lnSpc>
@@ -6159,7 +6191,7 @@
           <a:bodyPr wrap="square" rtlCol="0" anchor="ctr"/>
           <a:lstStyle/>
           <a:p>
-            <a:pPr indent="0" marL="0">
+            <a:pPr marL="0" indent="0">
               <a:lnSpc>
                 <a:spcPts val="1300"/>
               </a:lnSpc>
@@ -6228,7 +6260,7 @@
           <a:bodyPr wrap="square" rtlCol="0" anchor="ctr"/>
           <a:lstStyle/>
           <a:p>
-            <a:pPr indent="0" marL="0">
+            <a:pPr marL="0" indent="0">
               <a:buNone/>
             </a:pPr>
             <a:r>
@@ -6267,7 +6299,7 @@
           <a:bodyPr wrap="square" rtlCol="0" anchor="ctr"/>
           <a:lstStyle/>
           <a:p>
-            <a:pPr indent="0" marL="0">
+            <a:pPr marL="0" indent="0">
               <a:lnSpc>
                 <a:spcPts val="1600"/>
               </a:lnSpc>
@@ -6309,7 +6341,7 @@
           <a:bodyPr wrap="square" rtlCol="0" anchor="ctr"/>
           <a:lstStyle/>
           <a:p>
-            <a:pPr indent="0" marL="0">
+            <a:pPr marL="0" indent="0">
               <a:lnSpc>
                 <a:spcPts val="1300"/>
               </a:lnSpc>
@@ -6378,7 +6410,7 @@
           <a:bodyPr wrap="square" rtlCol="0" anchor="ctr"/>
           <a:lstStyle/>
           <a:p>
-            <a:pPr indent="0" marL="0">
+            <a:pPr marL="0" indent="0">
               <a:buNone/>
             </a:pPr>
             <a:r>
@@ -6417,7 +6449,7 @@
           <a:bodyPr wrap="square" rtlCol="0" anchor="ctr"/>
           <a:lstStyle/>
           <a:p>
-            <a:pPr indent="0" marL="0">
+            <a:pPr marL="0" indent="0">
               <a:lnSpc>
                 <a:spcPts val="1600"/>
               </a:lnSpc>
@@ -6459,7 +6491,7 @@
           <a:bodyPr wrap="square" rtlCol="0" anchor="ctr"/>
           <a:lstStyle/>
           <a:p>
-            <a:pPr indent="0" marL="0">
+            <a:pPr marL="0" indent="0">
               <a:lnSpc>
                 <a:spcPts val="1300"/>
               </a:lnSpc>
@@ -6501,7 +6533,7 @@
           <a:bodyPr wrap="square" rtlCol="0" anchor="ctr"/>
           <a:lstStyle/>
           <a:p>
-            <a:pPr algn="l" indent="0" marL="0">
+            <a:pPr marL="0" indent="0" algn="l">
               <a:buNone/>
             </a:pPr>
             <a:r>
@@ -6540,7 +6572,7 @@
           <a:bodyPr wrap="square" rtlCol="0" anchor="ctr"/>
           <a:lstStyle/>
           <a:p>
-            <a:pPr algn="r" indent="0" marL="0">
+            <a:pPr marL="0" indent="0" algn="r">
               <a:buNone/>
             </a:pPr>
             <a:r>
@@ -6574,6 +6606,7 @@
         <a:solidFill>
           <a:srgbClr val="F7F8FC"/>
         </a:solidFill>
+        <a:effectLst/>
       </p:bgPr>
     </p:bg>
     <p:spTree>
@@ -6611,11 +6644,11 @@
           <a:bodyPr wrap="square" rtlCol="0" anchor="ctr"/>
           <a:lstStyle/>
           <a:p>
-            <a:pPr indent="0" marL="0">
-              <a:buNone/>
-            </a:pPr>
-            <a:r>
-              <a:rPr lang="en-US" sz="1300" b="1" spc="200" kern="0" dirty="0">
+            <a:pPr marL="0" indent="0">
+              <a:buNone/>
+            </a:pPr>
+            <a:r>
+              <a:rPr lang="en-US" sz="1300" b="1" kern="0" spc="200" dirty="0">
                 <a:solidFill>
                   <a:srgbClr val="6366F1"/>
                 </a:solidFill>
@@ -6650,7 +6683,7 @@
           <a:bodyPr wrap="square" rtlCol="0" anchor="ctr"/>
           <a:lstStyle/>
           <a:p>
-            <a:pPr indent="0" marL="0">
+            <a:pPr marL="0" indent="0">
               <a:buNone/>
             </a:pPr>
             <a:r>
@@ -6709,7 +6742,7 @@
           <a:bodyPr wrap="square" rtlCol="0" anchor="ctr"/>
           <a:lstStyle/>
           <a:p>
-            <a:pPr indent="0" marL="0">
+            <a:pPr marL="0" indent="0">
               <a:buNone/>
             </a:pPr>
             <a:r>
@@ -6748,7 +6781,7 @@
           <a:bodyPr wrap="square" rtlCol="0" anchor="ctr"/>
           <a:lstStyle/>
           <a:p>
-            <a:pPr indent="0" marL="0">
+            <a:pPr marL="0" indent="0">
               <a:buNone/>
             </a:pPr>
             <a:r>
@@ -6807,7 +6840,7 @@
           <a:bodyPr wrap="square" rtlCol="0" anchor="ctr"/>
           <a:lstStyle/>
           <a:p>
-            <a:pPr indent="0" marL="0">
+            <a:pPr marL="0" indent="0">
               <a:buNone/>
             </a:pPr>
             <a:r>
@@ -6846,7 +6879,7 @@
           <a:bodyPr wrap="square" rtlCol="0" anchor="ctr"/>
           <a:lstStyle/>
           <a:p>
-            <a:pPr indent="0" marL="0">
+            <a:pPr marL="0" indent="0">
               <a:buNone/>
             </a:pPr>
             <a:r>
@@ -6905,7 +6938,7 @@
           <a:bodyPr wrap="square" rtlCol="0" anchor="ctr"/>
           <a:lstStyle/>
           <a:p>
-            <a:pPr indent="0" marL="0">
+            <a:pPr marL="0" indent="0">
               <a:buNone/>
             </a:pPr>
             <a:r>
@@ -6944,7 +6977,7 @@
           <a:bodyPr wrap="square" rtlCol="0" anchor="ctr"/>
           <a:lstStyle/>
           <a:p>
-            <a:pPr indent="0" marL="0">
+            <a:pPr marL="0" indent="0">
               <a:buNone/>
             </a:pPr>
             <a:r>
@@ -7003,7 +7036,7 @@
           <a:bodyPr wrap="square" rtlCol="0" anchor="ctr"/>
           <a:lstStyle/>
           <a:p>
-            <a:pPr indent="0" marL="0">
+            <a:pPr marL="0" indent="0">
               <a:buNone/>
             </a:pPr>
             <a:r>
@@ -7042,7 +7075,7 @@
           <a:bodyPr wrap="square" rtlCol="0" anchor="ctr"/>
           <a:lstStyle/>
           <a:p>
-            <a:pPr indent="0" marL="0">
+            <a:pPr marL="0" indent="0">
               <a:buNone/>
             </a:pPr>
             <a:r>
@@ -7101,7 +7134,7 @@
           <a:bodyPr wrap="square" rtlCol="0" anchor="ctr"/>
           <a:lstStyle/>
           <a:p>
-            <a:pPr indent="0" marL="0">
+            <a:pPr marL="0" indent="0">
               <a:buNone/>
             </a:pPr>
             <a:r>
@@ -7140,7 +7173,7 @@
           <a:bodyPr wrap="square" rtlCol="0" anchor="ctr"/>
           <a:lstStyle/>
           <a:p>
-            <a:pPr indent="0" marL="0">
+            <a:pPr marL="0" indent="0">
               <a:buNone/>
             </a:pPr>
             <a:r>
@@ -7199,7 +7232,7 @@
           <a:bodyPr wrap="square" rtlCol="0" anchor="ctr"/>
           <a:lstStyle/>
           <a:p>
-            <a:pPr indent="0" marL="0">
+            <a:pPr marL="0" indent="0">
               <a:buNone/>
             </a:pPr>
             <a:r>
@@ -7238,7 +7271,7 @@
           <a:bodyPr wrap="square" rtlCol="0" anchor="ctr"/>
           <a:lstStyle/>
           <a:p>
-            <a:pPr indent="0" marL="0">
+            <a:pPr marL="0" indent="0">
               <a:buNone/>
             </a:pPr>
             <a:r>
@@ -7277,7 +7310,7 @@
           <a:bodyPr wrap="square" rtlCol="0" anchor="ctr"/>
           <a:lstStyle/>
           <a:p>
-            <a:pPr algn="l" indent="0" marL="0">
+            <a:pPr marL="0" indent="0" algn="l">
               <a:buNone/>
             </a:pPr>
             <a:r>
@@ -7316,7 +7349,7 @@
           <a:bodyPr wrap="square" rtlCol="0" anchor="ctr"/>
           <a:lstStyle/>
           <a:p>
-            <a:pPr algn="r" indent="0" marL="0">
+            <a:pPr marL="0" indent="0" algn="r">
               <a:buNone/>
             </a:pPr>
             <a:r>
@@ -7350,6 +7383,7 @@
         <a:solidFill>
           <a:srgbClr val="F7F8FC"/>
         </a:solidFill>
+        <a:effectLst/>
       </p:bgPr>
     </p:bg>
     <p:spTree>
@@ -7387,11 +7421,11 @@
           <a:bodyPr wrap="square" rtlCol="0" anchor="ctr"/>
           <a:lstStyle/>
           <a:p>
-            <a:pPr indent="0" marL="0">
-              <a:buNone/>
-            </a:pPr>
-            <a:r>
-              <a:rPr lang="en-US" sz="1300" b="1" spc="200" kern="0" dirty="0">
+            <a:pPr marL="0" indent="0">
+              <a:buNone/>
+            </a:pPr>
+            <a:r>
+              <a:rPr lang="en-US" sz="1300" b="1" kern="0" spc="200" dirty="0">
                 <a:solidFill>
                   <a:srgbClr val="6366F1"/>
                 </a:solidFill>
@@ -7426,7 +7460,7 @@
           <a:bodyPr wrap="square" rtlCol="0" anchor="ctr"/>
           <a:lstStyle/>
           <a:p>
-            <a:pPr indent="0" marL="0">
+            <a:pPr marL="0" indent="0">
               <a:buNone/>
             </a:pPr>
             <a:r>
@@ -7465,7 +7499,7 @@
           <a:bodyPr wrap="square" rtlCol="0" anchor="ctr"/>
           <a:lstStyle/>
           <a:p>
-            <a:pPr indent="0" marL="0">
+            <a:pPr marL="0" indent="0">
               <a:buNone/>
             </a:pPr>
             <a:r>
@@ -7485,15 +7519,15 @@
       </p:sp>
       <p:pic>
         <p:nvPicPr>
-          <p:cNvPr id="5" name="Image 0" descr="/home/claude/appverse-docs/diagrams/architecture_diagram.png">    </p:cNvPr>
+          <p:cNvPr id="5" name="Image 0" descr="/home/claude/appverse-docs/diagrams/architecture_diagram.png"/>
           <p:cNvPicPr>
             <a:picLocks noChangeAspect="1"/>
           </p:cNvPicPr>
           <p:nvPr/>
         </p:nvPicPr>
         <p:blipFill>
-          <a:blip r:embed="rId1"/>
-          <a:srcRect l="0" r="0" t="0" b="0"/>
+          <a:blip r:embed="rId3"/>
+          <a:srcRect/>
           <a:stretch/>
         </p:blipFill>
         <p:spPr>
@@ -7527,7 +7561,7 @@
           <a:bodyPr wrap="square" rtlCol="0" anchor="ctr"/>
           <a:lstStyle/>
           <a:p>
-            <a:pPr algn="l" indent="0" marL="0">
+            <a:pPr marL="0" indent="0" algn="l">
               <a:buNone/>
             </a:pPr>
             <a:r>
@@ -7566,7 +7600,7 @@
           <a:bodyPr wrap="square" rtlCol="0" anchor="ctr"/>
           <a:lstStyle/>
           <a:p>
-            <a:pPr algn="r" indent="0" marL="0">
+            <a:pPr marL="0" indent="0" algn="r">
               <a:buNone/>
             </a:pPr>
             <a:r>
@@ -7600,6 +7634,7 @@
         <a:solidFill>
           <a:srgbClr val="F7F8FC"/>
         </a:solidFill>
+        <a:effectLst/>
       </p:bgPr>
     </p:bg>
     <p:spTree>
@@ -7637,11 +7672,11 @@
           <a:bodyPr wrap="square" rtlCol="0" anchor="ctr"/>
           <a:lstStyle/>
           <a:p>
-            <a:pPr indent="0" marL="0">
-              <a:buNone/>
-            </a:pPr>
-            <a:r>
-              <a:rPr lang="en-US" sz="1300" b="1" spc="200" kern="0" dirty="0">
+            <a:pPr marL="0" indent="0">
+              <a:buNone/>
+            </a:pPr>
+            <a:r>
+              <a:rPr lang="en-US" sz="1300" b="1" kern="0" spc="200" dirty="0">
                 <a:solidFill>
                   <a:srgbClr val="6366F1"/>
                 </a:solidFill>
@@ -7676,7 +7711,7 @@
           <a:bodyPr wrap="square" rtlCol="0" anchor="ctr"/>
           <a:lstStyle/>
           <a:p>
-            <a:pPr indent="0" marL="0">
+            <a:pPr marL="0" indent="0">
               <a:buNone/>
             </a:pPr>
             <a:r>
@@ -7715,7 +7750,7 @@
           <a:bodyPr wrap="square" rtlCol="0" anchor="ctr"/>
           <a:lstStyle/>
           <a:p>
-            <a:pPr indent="0" marL="0">
+            <a:pPr marL="0" indent="0">
               <a:buNone/>
             </a:pPr>
             <a:r>
@@ -7735,15 +7770,15 @@
       </p:sp>
       <p:pic>
         <p:nvPicPr>
-          <p:cNvPr id="5" name="Image 0" descr="/home/claude/appverse-docs/diagrams/er_diagram.png">    </p:cNvPr>
+          <p:cNvPr id="5" name="Image 0" descr="/home/claude/appverse-docs/diagrams/er_diagram.png"/>
           <p:cNvPicPr>
             <a:picLocks noChangeAspect="1"/>
           </p:cNvPicPr>
           <p:nvPr/>
         </p:nvPicPr>
         <p:blipFill>
-          <a:blip r:embed="rId1"/>
-          <a:srcRect l="0" r="0" t="0" b="0"/>
+          <a:blip r:embed="rId3"/>
+          <a:srcRect/>
           <a:stretch/>
         </p:blipFill>
         <p:spPr>
@@ -7777,7 +7812,7 @@
           <a:bodyPr wrap="square" rtlCol="0" anchor="ctr"/>
           <a:lstStyle/>
           <a:p>
-            <a:pPr algn="l" indent="0" marL="0">
+            <a:pPr marL="0" indent="0" algn="l">
               <a:buNone/>
             </a:pPr>
             <a:r>
@@ -7816,7 +7851,7 @@
           <a:bodyPr wrap="square" rtlCol="0" anchor="ctr"/>
           <a:lstStyle/>
           <a:p>
-            <a:pPr algn="r" indent="0" marL="0">
+            <a:pPr marL="0" indent="0" algn="r">
               <a:buNone/>
             </a:pPr>
             <a:r>
@@ -7850,6 +7885,7 @@
         <a:solidFill>
           <a:srgbClr val="F7F8FC"/>
         </a:solidFill>
+        <a:effectLst/>
       </p:bgPr>
     </p:bg>
     <p:spTree>
@@ -7887,11 +7923,11 @@
           <a:bodyPr wrap="square" rtlCol="0" anchor="ctr"/>
           <a:lstStyle/>
           <a:p>
-            <a:pPr indent="0" marL="0">
-              <a:buNone/>
-            </a:pPr>
-            <a:r>
-              <a:rPr lang="en-US" sz="1300" b="1" spc="200" kern="0" dirty="0">
+            <a:pPr marL="0" indent="0">
+              <a:buNone/>
+            </a:pPr>
+            <a:r>
+              <a:rPr lang="en-US" sz="1300" b="1" kern="0" spc="200" dirty="0">
                 <a:solidFill>
                   <a:srgbClr val="6366F1"/>
                 </a:solidFill>
@@ -7926,7 +7962,7 @@
           <a:bodyPr wrap="square" rtlCol="0" anchor="ctr"/>
           <a:lstStyle/>
           <a:p>
-            <a:pPr indent="0" marL="0">
+            <a:pPr marL="0" indent="0">
               <a:buNone/>
             </a:pPr>
             <a:r>
@@ -7965,7 +8001,7 @@
           <a:bodyPr wrap="square" rtlCol="0" anchor="ctr"/>
           <a:lstStyle/>
           <a:p>
-            <a:pPr indent="0" marL="0">
+            <a:pPr marL="0" indent="0">
               <a:buNone/>
             </a:pPr>
             <a:r>
@@ -7985,15 +8021,15 @@
       </p:sp>
       <p:pic>
         <p:nvPicPr>
-          <p:cNvPr id="5" name="Image 0" descr="/home/claude/appverse-docs/diagrams/class_diagram.png">    </p:cNvPr>
+          <p:cNvPr id="5" name="Image 0" descr="/home/claude/appverse-docs/diagrams/class_diagram.png"/>
           <p:cNvPicPr>
             <a:picLocks noChangeAspect="1"/>
           </p:cNvPicPr>
           <p:nvPr/>
         </p:nvPicPr>
         <p:blipFill>
-          <a:blip r:embed="rId1"/>
-          <a:srcRect l="0" r="0" t="0" b="0"/>
+          <a:blip r:embed="rId3"/>
+          <a:srcRect/>
           <a:stretch/>
         </p:blipFill>
         <p:spPr>
@@ -8027,7 +8063,7 @@
           <a:bodyPr wrap="square" rtlCol="0" anchor="ctr"/>
           <a:lstStyle/>
           <a:p>
-            <a:pPr algn="l" indent="0" marL="0">
+            <a:pPr marL="0" indent="0" algn="l">
               <a:buNone/>
             </a:pPr>
             <a:r>
@@ -8066,7 +8102,7 @@
           <a:bodyPr wrap="square" rtlCol="0" anchor="ctr"/>
           <a:lstStyle/>
           <a:p>
-            <a:pPr algn="r" indent="0" marL="0">
+            <a:pPr marL="0" indent="0" algn="r">
               <a:buNone/>
             </a:pPr>
             <a:r>
@@ -8100,6 +8136,7 @@
         <a:solidFill>
           <a:srgbClr val="F7F8FC"/>
         </a:solidFill>
+        <a:effectLst/>
       </p:bgPr>
     </p:bg>
     <p:spTree>
@@ -8137,11 +8174,11 @@
           <a:bodyPr wrap="square" rtlCol="0" anchor="ctr"/>
           <a:lstStyle/>
           <a:p>
-            <a:pPr indent="0" marL="0">
-              <a:buNone/>
-            </a:pPr>
-            <a:r>
-              <a:rPr lang="en-US" sz="1300" b="1" spc="200" kern="0" dirty="0">
+            <a:pPr marL="0" indent="0">
+              <a:buNone/>
+            </a:pPr>
+            <a:r>
+              <a:rPr lang="en-US" sz="1300" b="1" kern="0" spc="200" dirty="0">
                 <a:solidFill>
                   <a:srgbClr val="6366F1"/>
                 </a:solidFill>
@@ -8176,7 +8213,7 @@
           <a:bodyPr wrap="square" rtlCol="0" anchor="ctr"/>
           <a:lstStyle/>
           <a:p>
-            <a:pPr indent="0" marL="0">
+            <a:pPr marL="0" indent="0">
               <a:buNone/>
             </a:pPr>
             <a:r>
@@ -8215,7 +8252,7 @@
           <a:bodyPr wrap="square" rtlCol="0" anchor="ctr"/>
           <a:lstStyle/>
           <a:p>
-            <a:pPr indent="0" marL="0">
+            <a:pPr marL="0" indent="0">
               <a:buNone/>
             </a:pPr>
             <a:r>
@@ -8235,15 +8272,15 @@
       </p:sp>
       <p:pic>
         <p:nvPicPr>
-          <p:cNvPr id="5" name="Image 0" descr="/home/claude/appverse-docs/diagrams/dfd_diagram.png">    </p:cNvPr>
+          <p:cNvPr id="5" name="Image 0" descr="/home/claude/appverse-docs/diagrams/dfd_diagram.png"/>
           <p:cNvPicPr>
             <a:picLocks noChangeAspect="1"/>
           </p:cNvPicPr>
           <p:nvPr/>
         </p:nvPicPr>
         <p:blipFill>
-          <a:blip r:embed="rId1"/>
-          <a:srcRect l="0" r="0" t="0" b="0"/>
+          <a:blip r:embed="rId3"/>
+          <a:srcRect/>
           <a:stretch/>
         </p:blipFill>
         <p:spPr>
@@ -8277,7 +8314,7 @@
           <a:bodyPr wrap="square" rtlCol="0" anchor="ctr"/>
           <a:lstStyle/>
           <a:p>
-            <a:pPr algn="l" indent="0" marL="0">
+            <a:pPr marL="0" indent="0" algn="l">
               <a:buNone/>
             </a:pPr>
             <a:r>
@@ -8316,7 +8353,7 @@
           <a:bodyPr wrap="square" rtlCol="0" anchor="ctr"/>
           <a:lstStyle/>
           <a:p>
-            <a:pPr algn="r" indent="0" marL="0">
+            <a:pPr marL="0" indent="0" algn="r">
               <a:buNone/>
             </a:pPr>
             <a:r>
@@ -8350,6 +8387,7 @@
         <a:solidFill>
           <a:srgbClr val="0A0E1A"/>
         </a:solidFill>
+        <a:effectLst/>
       </p:bgPr>
     </p:bg>
     <p:spTree>
@@ -8387,11 +8425,11 @@
           <a:bodyPr wrap="square" rtlCol="0" anchor="ctr"/>
           <a:lstStyle/>
           <a:p>
-            <a:pPr indent="0" marL="0">
-              <a:buNone/>
-            </a:pPr>
-            <a:r>
-              <a:rPr lang="en-US" sz="1300" b="1" spc="200" kern="0" dirty="0">
+            <a:pPr marL="0" indent="0">
+              <a:buNone/>
+            </a:pPr>
+            <a:r>
+              <a:rPr lang="en-US" sz="1300" b="1" kern="0" spc="200" dirty="0">
                 <a:solidFill>
                   <a:srgbClr val="22D3B6"/>
                 </a:solidFill>
@@ -8426,7 +8464,7 @@
           <a:bodyPr wrap="square" rtlCol="0" anchor="ctr"/>
           <a:lstStyle/>
           <a:p>
-            <a:pPr indent="0" marL="0">
+            <a:pPr marL="0" indent="0">
               <a:buNone/>
             </a:pPr>
             <a:r>
@@ -8512,7 +8550,7 @@
           <a:bodyPr wrap="square" rtlCol="0" anchor="ctr"/>
           <a:lstStyle/>
           <a:p>
-            <a:pPr indent="0" marL="0">
+            <a:pPr marL="0" indent="0">
               <a:buNone/>
             </a:pPr>
             <a:r>
@@ -8551,7 +8589,7 @@
           <a:bodyPr wrap="square" rtlCol="0" anchor="ctr"/>
           <a:lstStyle/>
           <a:p>
-            <a:pPr indent="0" marL="0">
+            <a:pPr marL="0" indent="0">
               <a:lnSpc>
                 <a:spcPts val="1400"/>
               </a:lnSpc>
@@ -8640,7 +8678,7 @@
           <a:bodyPr wrap="square" rtlCol="0" anchor="ctr"/>
           <a:lstStyle/>
           <a:p>
-            <a:pPr indent="0" marL="0">
+            <a:pPr marL="0" indent="0">
               <a:buNone/>
             </a:pPr>
             <a:r>
@@ -8679,7 +8717,7 @@
           <a:bodyPr wrap="square" rtlCol="0" anchor="ctr"/>
           <a:lstStyle/>
           <a:p>
-            <a:pPr indent="0" marL="0">
+            <a:pPr marL="0" indent="0">
               <a:lnSpc>
                 <a:spcPts val="1400"/>
               </a:lnSpc>
@@ -8768,7 +8806,7 @@
           <a:bodyPr wrap="square" rtlCol="0" anchor="ctr"/>
           <a:lstStyle/>
           <a:p>
-            <a:pPr indent="0" marL="0">
+            <a:pPr marL="0" indent="0">
               <a:buNone/>
             </a:pPr>
             <a:r>
@@ -8807,7 +8845,7 @@
           <a:bodyPr wrap="square" rtlCol="0" anchor="ctr"/>
           <a:lstStyle/>
           <a:p>
-            <a:pPr indent="0" marL="0">
+            <a:pPr marL="0" indent="0">
               <a:lnSpc>
                 <a:spcPts val="1400"/>
               </a:lnSpc>
@@ -8896,7 +8934,7 @@
           <a:bodyPr wrap="square" rtlCol="0" anchor="ctr"/>
           <a:lstStyle/>
           <a:p>
-            <a:pPr indent="0" marL="0">
+            <a:pPr marL="0" indent="0">
               <a:buNone/>
             </a:pPr>
             <a:r>
@@ -8935,7 +8973,7 @@
           <a:bodyPr wrap="square" rtlCol="0" anchor="ctr"/>
           <a:lstStyle/>
           <a:p>
-            <a:pPr indent="0" marL="0">
+            <a:pPr marL="0" indent="0">
               <a:lnSpc>
                 <a:spcPts val="1400"/>
               </a:lnSpc>
@@ -9024,7 +9062,7 @@
           <a:bodyPr wrap="square" rtlCol="0" anchor="ctr"/>
           <a:lstStyle/>
           <a:p>
-            <a:pPr indent="0" marL="0">
+            <a:pPr marL="0" indent="0">
               <a:buNone/>
             </a:pPr>
             <a:r>
@@ -9063,7 +9101,7 @@
           <a:bodyPr wrap="square" rtlCol="0" anchor="ctr"/>
           <a:lstStyle/>
           <a:p>
-            <a:pPr indent="0" marL="0">
+            <a:pPr marL="0" indent="0">
               <a:lnSpc>
                 <a:spcPts val="1400"/>
               </a:lnSpc>
@@ -9152,7 +9190,7 @@
           <a:bodyPr wrap="square" rtlCol="0" anchor="ctr"/>
           <a:lstStyle/>
           <a:p>
-            <a:pPr indent="0" marL="0">
+            <a:pPr marL="0" indent="0">
               <a:buNone/>
             </a:pPr>
             <a:r>
@@ -9191,7 +9229,7 @@
           <a:bodyPr wrap="square" rtlCol="0" anchor="ctr"/>
           <a:lstStyle/>
           <a:p>
-            <a:pPr indent="0" marL="0">
+            <a:pPr marL="0" indent="0">
               <a:lnSpc>
                 <a:spcPts val="1400"/>
               </a:lnSpc>
@@ -9233,7 +9271,7 @@
           <a:bodyPr wrap="square" rtlCol="0" anchor="ctr"/>
           <a:lstStyle/>
           <a:p>
-            <a:pPr algn="l" indent="0" marL="0">
+            <a:pPr marL="0" indent="0" algn="l">
               <a:buNone/>
             </a:pPr>
             <a:r>
@@ -9272,7 +9310,7 @@
           <a:bodyPr wrap="square" rtlCol="0" anchor="ctr"/>
           <a:lstStyle/>
           <a:p>
-            <a:pPr algn="r" indent="0" marL="0">
+            <a:pPr marL="0" indent="0" algn="r">
               <a:buNone/>
             </a:pPr>
             <a:r>
@@ -9591,4 +9629,299 @@
     </a:ext>
   </a:extLst>
 </a:theme>
+</file>
+
+<file path=ppt/theme/theme2.xml><?xml version="1.0" encoding="utf-8"?>
+<a:theme xmlns:a="http://schemas.openxmlformats.org/drawingml/2006/main" name="Office Theme">
+  <a:themeElements>
+    <a:clrScheme name="Office">
+      <a:dk1>
+        <a:sysClr val="windowText" lastClr="000000"/>
+      </a:dk1>
+      <a:lt1>
+        <a:sysClr val="window" lastClr="FFFFFF"/>
+      </a:lt1>
+      <a:dk2>
+        <a:srgbClr val="44546A"/>
+      </a:dk2>
+      <a:lt2>
+        <a:srgbClr val="E7E6E6"/>
+      </a:lt2>
+      <a:accent1>
+        <a:srgbClr val="4472C4"/>
+      </a:accent1>
+      <a:accent2>
+        <a:srgbClr val="ED7D31"/>
+      </a:accent2>
+      <a:accent3>
+        <a:srgbClr val="A5A5A5"/>
+      </a:accent3>
+      <a:accent4>
+        <a:srgbClr val="FFC000"/>
+      </a:accent4>
+      <a:accent5>
+        <a:srgbClr val="5B9BD5"/>
+      </a:accent5>
+      <a:accent6>
+        <a:srgbClr val="70AD47"/>
+      </a:accent6>
+      <a:hlink>
+        <a:srgbClr val="0563C1"/>
+      </a:hlink>
+      <a:folHlink>
+        <a:srgbClr val="954F72"/>
+      </a:folHlink>
+    </a:clrScheme>
+    <a:fontScheme name="Office">
+      <a:majorFont>
+        <a:latin typeface="Calibri Light" panose="020F0302020204030204"/>
+        <a:ea typeface=""/>
+        <a:cs typeface=""/>
+        <a:font script="Jpan" typeface="游ゴシック Light"/>
+        <a:font script="Hang" typeface="맑은 고딕"/>
+        <a:font script="Hans" typeface="等线 Light"/>
+        <a:font script="Hant" typeface="新細明體"/>
+        <a:font script="Arab" typeface="Times New Roman"/>
+        <a:font script="Hebr" typeface="Times New Roman"/>
+        <a:font script="Thai" typeface="Angsana New"/>
+        <a:font script="Ethi" typeface="Nyala"/>
+        <a:font script="Beng" typeface="Vrinda"/>
+        <a:font script="Gujr" typeface="Shruti"/>
+        <a:font script="Khmr" typeface="MoolBoran"/>
+        <a:font script="Knda" typeface="Tunga"/>
+        <a:font script="Guru" typeface="Raavi"/>
+        <a:font script="Cans" typeface="Euphemia"/>
+        <a:font script="Cher" typeface="Plantagenet Cherokee"/>
+        <a:font script="Yiii" typeface="Microsoft Yi Baiti"/>
+        <a:font script="Tibt" typeface="Microsoft Himalaya"/>
+        <a:font script="Thaa" typeface="MV Boli"/>
+        <a:font script="Deva" typeface="Mangal"/>
+        <a:font script="Telu" typeface="Gautami"/>
+        <a:font script="Taml" typeface="Latha"/>
+        <a:font script="Syrc" typeface="Estrangelo Edessa"/>
+        <a:font script="Orya" typeface="Kalinga"/>
+        <a:font script="Mlym" typeface="Kartika"/>
+        <a:font script="Laoo" typeface="DokChampa"/>
+        <a:font script="Sinh" typeface="Iskoola Pota"/>
+        <a:font script="Mong" typeface="Mongolian Baiti"/>
+        <a:font script="Viet" typeface="Times New Roman"/>
+        <a:font script="Uigh" typeface="Microsoft Uighur"/>
+        <a:font script="Geor" typeface="Sylfaen"/>
+        <a:font script="Armn" typeface="Arial"/>
+        <a:font script="Bugi" typeface="Leelawadee UI"/>
+        <a:font script="Bopo" typeface="Microsoft JhengHei"/>
+        <a:font script="Java" typeface="Javanese Text"/>
+        <a:font script="Lisu" typeface="Segoe UI"/>
+        <a:font script="Mymr" typeface="Myanmar Text"/>
+        <a:font script="Nkoo" typeface="Ebrima"/>
+        <a:font script="Olck" typeface="Nirmala UI"/>
+        <a:font script="Osma" typeface="Ebrima"/>
+        <a:font script="Phag" typeface="Phagspa"/>
+        <a:font script="Syrn" typeface="Estrangelo Edessa"/>
+        <a:font script="Syrj" typeface="Estrangelo Edessa"/>
+        <a:font script="Syre" typeface="Estrangelo Edessa"/>
+        <a:font script="Sora" typeface="Nirmala UI"/>
+        <a:font script="Tale" typeface="Microsoft Tai Le"/>
+        <a:font script="Talu" typeface="Microsoft New Tai Lue"/>
+        <a:font script="Tfng" typeface="Ebrima"/>
+      </a:majorFont>
+      <a:minorFont>
+        <a:latin typeface="Calibri" panose="020F0502020204030204"/>
+        <a:ea typeface=""/>
+        <a:cs typeface=""/>
+        <a:font script="Jpan" typeface="游ゴシック"/>
+        <a:font script="Hang" typeface="맑은 고딕"/>
+        <a:font script="Hans" typeface="等线"/>
+        <a:font script="Hant" typeface="新細明體"/>
+        <a:font script="Arab" typeface="Arial"/>
+        <a:font script="Hebr" typeface="Arial"/>
+        <a:font script="Thai" typeface="Cordia New"/>
+        <a:font script="Ethi" typeface="Nyala"/>
+        <a:font script="Beng" typeface="Vrinda"/>
+        <a:font script="Gujr" typeface="Shruti"/>
+        <a:font script="Khmr" typeface="DaunPenh"/>
+        <a:font script="Knda" typeface="Tunga"/>
+        <a:font script="Guru" typeface="Raavi"/>
+        <a:font script="Cans" typeface="Euphemia"/>
+        <a:font script="Cher" typeface="Plantagenet Cherokee"/>
+        <a:font script="Yiii" typeface="Microsoft Yi Baiti"/>
+        <a:font script="Tibt" typeface="Microsoft Himalaya"/>
+        <a:font script="Thaa" typeface="MV Boli"/>
+        <a:font script="Deva" typeface="Mangal"/>
+        <a:font script="Telu" typeface="Gautami"/>
+        <a:font script="Taml" typeface="Latha"/>
+        <a:font script="Syrc" typeface="Estrangelo Edessa"/>
+        <a:font script="Orya" typeface="Kalinga"/>
+        <a:font script="Mlym" typeface="Kartika"/>
+        <a:font script="Laoo" typeface="DokChampa"/>
+        <a:font script="Sinh" typeface="Iskoola Pota"/>
+        <a:font script="Mong" typeface="Mongolian Baiti"/>
+        <a:font script="Viet" typeface="Arial"/>
+        <a:font script="Uigh" typeface="Microsoft Uighur"/>
+        <a:font script="Geor" typeface="Sylfaen"/>
+        <a:font script="Armn" typeface="Arial"/>
+        <a:font script="Bugi" typeface="Leelawadee UI"/>
+        <a:font script="Bopo" typeface="Microsoft JhengHei"/>
+        <a:font script="Java" typeface="Javanese Text"/>
+        <a:font script="Lisu" typeface="Segoe UI"/>
+        <a:font script="Mymr" typeface="Myanmar Text"/>
+        <a:font script="Nkoo" typeface="Ebrima"/>
+        <a:font script="Olck" typeface="Nirmala UI"/>
+        <a:font script="Osma" typeface="Ebrima"/>
+        <a:font script="Phag" typeface="Phagspa"/>
+        <a:font script="Syrn" typeface="Estrangelo Edessa"/>
+        <a:font script="Syrj" typeface="Estrangelo Edessa"/>
+        <a:font script="Syre" typeface="Estrangelo Edessa"/>
+        <a:font script="Sora" typeface="Nirmala UI"/>
+        <a:font script="Tale" typeface="Microsoft Tai Le"/>
+        <a:font script="Talu" typeface="Microsoft New Tai Lue"/>
+        <a:font script="Tfng" typeface="Ebrima"/>
+      </a:minorFont>
+    </a:fontScheme>
+    <a:fmtScheme name="Office">
+      <a:fillStyleLst>
+        <a:solidFill>
+          <a:schemeClr val="phClr"/>
+        </a:solidFill>
+        <a:gradFill rotWithShape="1">
+          <a:gsLst>
+            <a:gs pos="0">
+              <a:schemeClr val="phClr">
+                <a:lumMod val="110000"/>
+                <a:satMod val="105000"/>
+                <a:tint val="67000"/>
+              </a:schemeClr>
+            </a:gs>
+            <a:gs pos="50000">
+              <a:schemeClr val="phClr">
+                <a:lumMod val="105000"/>
+                <a:satMod val="103000"/>
+                <a:tint val="73000"/>
+              </a:schemeClr>
+            </a:gs>
+            <a:gs pos="100000">
+              <a:schemeClr val="phClr">
+                <a:lumMod val="105000"/>
+                <a:satMod val="109000"/>
+                <a:tint val="81000"/>
+              </a:schemeClr>
+            </a:gs>
+          </a:gsLst>
+          <a:lin ang="5400000" scaled="0"/>
+        </a:gradFill>
+        <a:gradFill rotWithShape="1">
+          <a:gsLst>
+            <a:gs pos="0">
+              <a:schemeClr val="phClr">
+                <a:satMod val="103000"/>
+                <a:lumMod val="102000"/>
+                <a:tint val="94000"/>
+              </a:schemeClr>
+            </a:gs>
+            <a:gs pos="50000">
+              <a:schemeClr val="phClr">
+                <a:satMod val="110000"/>
+                <a:lumMod val="100000"/>
+                <a:shade val="100000"/>
+              </a:schemeClr>
+            </a:gs>
+            <a:gs pos="100000">
+              <a:schemeClr val="phClr">
+                <a:lumMod val="99000"/>
+                <a:satMod val="120000"/>
+                <a:shade val="78000"/>
+              </a:schemeClr>
+            </a:gs>
+          </a:gsLst>
+          <a:lin ang="5400000" scaled="0"/>
+        </a:gradFill>
+      </a:fillStyleLst>
+      <a:lnStyleLst>
+        <a:ln w="6350" cap="flat" cmpd="sng" algn="ctr">
+          <a:solidFill>
+            <a:schemeClr val="phClr"/>
+          </a:solidFill>
+          <a:prstDash val="solid"/>
+          <a:miter lim="800000"/>
+        </a:ln>
+        <a:ln w="12700" cap="flat" cmpd="sng" algn="ctr">
+          <a:solidFill>
+            <a:schemeClr val="phClr"/>
+          </a:solidFill>
+          <a:prstDash val="solid"/>
+          <a:miter lim="800000"/>
+        </a:ln>
+        <a:ln w="19050" cap="flat" cmpd="sng" algn="ctr">
+          <a:solidFill>
+            <a:schemeClr val="phClr"/>
+          </a:solidFill>
+          <a:prstDash val="solid"/>
+          <a:miter lim="800000"/>
+        </a:ln>
+      </a:lnStyleLst>
+      <a:effectStyleLst>
+        <a:effectStyle>
+          <a:effectLst/>
+        </a:effectStyle>
+        <a:effectStyle>
+          <a:effectLst/>
+        </a:effectStyle>
+        <a:effectStyle>
+          <a:effectLst>
+            <a:outerShdw blurRad="57150" dist="19050" dir="5400000" algn="ctr" rotWithShape="0">
+              <a:srgbClr val="000000">
+                <a:alpha val="63000"/>
+              </a:srgbClr>
+            </a:outerShdw>
+          </a:effectLst>
+        </a:effectStyle>
+      </a:effectStyleLst>
+      <a:bgFillStyleLst>
+        <a:solidFill>
+          <a:schemeClr val="phClr"/>
+        </a:solidFill>
+        <a:solidFill>
+          <a:schemeClr val="phClr">
+            <a:tint val="95000"/>
+            <a:satMod val="170000"/>
+          </a:schemeClr>
+        </a:solidFill>
+        <a:gradFill rotWithShape="1">
+          <a:gsLst>
+            <a:gs pos="0">
+              <a:schemeClr val="phClr">
+                <a:tint val="93000"/>
+                <a:satMod val="150000"/>
+                <a:shade val="98000"/>
+                <a:lumMod val="102000"/>
+              </a:schemeClr>
+            </a:gs>
+            <a:gs pos="50000">
+              <a:schemeClr val="phClr">
+                <a:tint val="98000"/>
+                <a:satMod val="130000"/>
+                <a:shade val="90000"/>
+                <a:lumMod val="103000"/>
+              </a:schemeClr>
+            </a:gs>
+            <a:gs pos="100000">
+              <a:schemeClr val="phClr">
+                <a:shade val="63000"/>
+                <a:satMod val="120000"/>
+              </a:schemeClr>
+            </a:gs>
+          </a:gsLst>
+          <a:lin ang="5400000" scaled="0"/>
+        </a:gradFill>
+      </a:bgFillStyleLst>
+    </a:fmtScheme>
+  </a:themeElements>
+  <a:objectDefaults/>
+  <a:extraClrSchemeLst/>
+  <a:extLst>
+    <a:ext uri="{05A4C25C-085E-4340-85A3-A5531E510DB2}">
+      <thm15:themeFamily xmlns:thm15="http://schemas.microsoft.com/office/thememl/2012/main" name="Office Theme" id="{62F939B6-93AF-4DB8-9C6B-D6C7DFDC589F}" vid="{4A3C46E8-61CC-4603-A589-7422A47A8E4A}"/>
+    </a:ext>
+  </a:extLst>
+</a:theme>
 </file>
</xml_diff>